<commit_message>
Expand the .pptx deck: richer per-slide content on the solution + working
Rewrote the deck content (16 slides) with substantive bullets explaining the
data foundation, the impact-score formula and its four axes, the enforcement
gap, the cost model, emerging-hotspot detrending, both ML models, and the
optimizer, with figures embedded and presenter notes. Content lives in
make_pptx.py rather than the sparse PITCH_DECK.md outline.

Co-Authored-By: Claude Opus 4.8 <noreply@anthropic.com>
Claude-Session: https://claude.ai/code/session_015xqbLKu3bgv91jhV9ZLyyM
</commit_message>
<xml_diff>
--- a/submission/ParkPulse_Pitch_Deck.pptx
+++ b/submission/ParkPulse_Pitch_Deck.pptx
@@ -18,6 +18,9 @@
     <p:sldId id="266" r:id="rId18"/>
     <p:sldId id="267" r:id="rId19"/>
     <p:sldId id="268" r:id="rId20"/>
+    <p:sldId id="269" r:id="rId21"/>
+    <p:sldId id="270" r:id="rId22"/>
+    <p:sldId id="271" r:id="rId23"/>
   </p:sldIdLst>
   <p:sldSz cx="12191695" cy="6858000" type="screen4x3"/>
   <p:notesSz cx="6858000" cy="9144000"/>
@@ -514,7 +517,7 @@
           <a:lstStyle/>
           <a:p>
             <a:r>
-              <a:t>A lane that gets a daily pre-dawn sweep can collect more tickets than the</a:t>
+              <a:t>Set up the visibility gap in 20 seconds.</a:t>
             </a:r>
           </a:p>
         </p:txBody>
@@ -584,7 +587,7 @@
           <a:lstStyle/>
           <a:p>
             <a:r>
-              <a:t>Being upfront here builds trust, with judges and with anyone who would deploy this. We never claim</a:t>
+              <a:t>Proactive, not just descriptive.</a:t>
             </a:r>
           </a:p>
         </p:txBody>
@@ -654,7 +657,7 @@
           <a:lstStyle/>
           <a:p>
             <a:r>
-              <a:t>This isn't a notebook screenshot. It's a real site that renders 2,500 cells</a:t>
+              <a:t>This is the genuine ML, and we are honest about its ceiling.</a:t>
             </a:r>
           </a:p>
         </p:txBody>
@@ -724,7 +727,217 @@
           <a:lstStyle/>
           <a:p>
             <a:r>
-              <a:t>Right now ParkPulse gives enforcement the prioritisation they're missing.</a:t>
+              <a:t>A second, cleaner ML win.</a:t>
+            </a:r>
+          </a:p>
+        </p:txBody>
+      </p:sp>
+      <p:sp>
+        <p:nvSpPr>
+          <p:cNvPr id="4" name="Slide Number Placeholder 3"/>
+          <p:cNvSpPr>
+            <a:spLocks noGrp="1"/>
+          </p:cNvSpPr>
+          <p:nvPr>
+            <p:ph type="sldNum" idx="5" sz="quarter"/>
+          </p:nvPr>
+        </p:nvSpPr>
+        <p:spPr/>
+      </p:sp>
+    </p:spTree>
+  </p:cSld>
+  <p:clrMapOvr>
+    <a:masterClrMapping/>
+  </p:clrMapOvr>
+</p:notes>
+</file>
+
+<file path=ppt/notesSlides/notesSlide13.xml><?xml version="1.0" encoding="utf-8"?>
+<p:notes xmlns:a="http://schemas.openxmlformats.org/drawingml/2006/main" xmlns:p="http://schemas.openxmlformats.org/presentationml/2006/main" xmlns:r="http://schemas.openxmlformats.org/officeDocument/2006/relationships">
+  <p:cSld>
+    <p:spTree>
+      <p:nvGrpSpPr>
+        <p:cNvPr id="1" name=""/>
+        <p:cNvGrpSpPr/>
+        <p:nvPr/>
+      </p:nvGrpSpPr>
+      <p:grpSpPr>
+        <a:xfrm>
+          <a:off x="0" y="0"/>
+          <a:ext cx="0" cy="0"/>
+          <a:chOff x="0" y="0"/>
+          <a:chExt cx="0" cy="0"/>
+        </a:xfrm>
+      </p:grpSpPr>
+      <p:sp>
+        <p:nvSpPr>
+          <p:cNvPr id="2" name="Slide Image Placeholder 1"/>
+          <p:cNvSpPr>
+            <a:spLocks noGrp="1"/>
+          </p:cNvSpPr>
+          <p:nvPr>
+            <p:ph type="sldImg" idx="2"/>
+          </p:nvPr>
+        </p:nvSpPr>
+        <p:spPr/>
+      </p:sp>
+      <p:sp>
+        <p:nvSpPr>
+          <p:cNvPr id="3" name="Notes Placeholder 2"/>
+          <p:cNvSpPr>
+            <a:spLocks noGrp="1"/>
+          </p:cNvSpPr>
+          <p:nvPr>
+            <p:ph type="body" idx="3" sz="quarter"/>
+          </p:nvPr>
+        </p:nvSpPr>
+        <p:spPr/>
+        <p:txBody>
+          <a:bodyPr/>
+          <a:lstStyle/>
+          <a:p>
+            <a:r>
+              <a:t>From insight to a deployable, costed plan.</a:t>
+            </a:r>
+          </a:p>
+        </p:txBody>
+      </p:sp>
+      <p:sp>
+        <p:nvSpPr>
+          <p:cNvPr id="4" name="Slide Number Placeholder 3"/>
+          <p:cNvSpPr>
+            <a:spLocks noGrp="1"/>
+          </p:cNvSpPr>
+          <p:nvPr>
+            <p:ph type="sldNum" idx="5" sz="quarter"/>
+          </p:nvPr>
+        </p:nvSpPr>
+        <p:spPr/>
+      </p:sp>
+    </p:spTree>
+  </p:cSld>
+  <p:clrMapOvr>
+    <a:masterClrMapping/>
+  </p:clrMapOvr>
+</p:notes>
+</file>
+
+<file path=ppt/notesSlides/notesSlide14.xml><?xml version="1.0" encoding="utf-8"?>
+<p:notes xmlns:a="http://schemas.openxmlformats.org/drawingml/2006/main" xmlns:p="http://schemas.openxmlformats.org/presentationml/2006/main" xmlns:r="http://schemas.openxmlformats.org/officeDocument/2006/relationships">
+  <p:cSld>
+    <p:spTree>
+      <p:nvGrpSpPr>
+        <p:cNvPr id="1" name=""/>
+        <p:cNvGrpSpPr/>
+        <p:nvPr/>
+      </p:nvGrpSpPr>
+      <p:grpSpPr>
+        <a:xfrm>
+          <a:off x="0" y="0"/>
+          <a:ext cx="0" cy="0"/>
+          <a:chOff x="0" y="0"/>
+          <a:chExt cx="0" cy="0"/>
+        </a:xfrm>
+      </p:grpSpPr>
+      <p:sp>
+        <p:nvSpPr>
+          <p:cNvPr id="2" name="Slide Image Placeholder 1"/>
+          <p:cNvSpPr>
+            <a:spLocks noGrp="1"/>
+          </p:cNvSpPr>
+          <p:nvPr>
+            <p:ph type="sldImg" idx="2"/>
+          </p:nvPr>
+        </p:nvSpPr>
+        <p:spPr/>
+      </p:sp>
+      <p:sp>
+        <p:nvSpPr>
+          <p:cNvPr id="3" name="Notes Placeholder 2"/>
+          <p:cNvSpPr>
+            <a:spLocks noGrp="1"/>
+          </p:cNvSpPr>
+          <p:nvPr>
+            <p:ph type="body" idx="3" sz="quarter"/>
+          </p:nvPr>
+        </p:nvSpPr>
+        <p:spPr/>
+        <p:txBody>
+          <a:bodyPr/>
+          <a:lstStyle/>
+          <a:p>
+            <a:r>
+              <a:t>Judges reward candor; so does anyone deploying this.</a:t>
+            </a:r>
+          </a:p>
+        </p:txBody>
+      </p:sp>
+      <p:sp>
+        <p:nvSpPr>
+          <p:cNvPr id="4" name="Slide Number Placeholder 3"/>
+          <p:cNvSpPr>
+            <a:spLocks noGrp="1"/>
+          </p:cNvSpPr>
+          <p:nvPr>
+            <p:ph type="sldNum" idx="5" sz="quarter"/>
+          </p:nvPr>
+        </p:nvSpPr>
+        <p:spPr/>
+      </p:sp>
+    </p:spTree>
+  </p:cSld>
+  <p:clrMapOvr>
+    <a:masterClrMapping/>
+  </p:clrMapOvr>
+</p:notes>
+</file>
+
+<file path=ppt/notesSlides/notesSlide15.xml><?xml version="1.0" encoding="utf-8"?>
+<p:notes xmlns:a="http://schemas.openxmlformats.org/drawingml/2006/main" xmlns:p="http://schemas.openxmlformats.org/presentationml/2006/main" xmlns:r="http://schemas.openxmlformats.org/officeDocument/2006/relationships">
+  <p:cSld>
+    <p:spTree>
+      <p:nvGrpSpPr>
+        <p:cNvPr id="1" name=""/>
+        <p:cNvGrpSpPr/>
+        <p:nvPr/>
+      </p:nvGrpSpPr>
+      <p:grpSpPr>
+        <a:xfrm>
+          <a:off x="0" y="0"/>
+          <a:ext cx="0" cy="0"/>
+          <a:chOff x="0" y="0"/>
+          <a:chExt cx="0" cy="0"/>
+        </a:xfrm>
+      </p:grpSpPr>
+      <p:sp>
+        <p:nvSpPr>
+          <p:cNvPr id="2" name="Slide Image Placeholder 1"/>
+          <p:cNvSpPr>
+            <a:spLocks noGrp="1"/>
+          </p:cNvSpPr>
+          <p:nvPr>
+            <p:ph type="sldImg" idx="2"/>
+          </p:nvPr>
+        </p:nvSpPr>
+        <p:spPr/>
+      </p:sp>
+      <p:sp>
+        <p:nvSpPr>
+          <p:cNvPr id="3" name="Notes Placeholder 2"/>
+          <p:cNvSpPr>
+            <a:spLocks noGrp="1"/>
+          </p:cNvSpPr>
+          <p:nvPr>
+            <p:ph type="body" idx="3" sz="quarter"/>
+          </p:nvPr>
+        </p:nvSpPr>
+        <p:spPr/>
+        <p:txBody>
+          <a:bodyPr/>
+          <a:lstStyle/>
+          <a:p>
+            <a:r>
+              <a:t>Close on deployability and the roadmap.</a:t>
             </a:r>
           </a:p>
         </p:txBody>
@@ -794,7 +1007,7 @@
           <a:lstStyle/>
           <a:p>
             <a:r>
-              <a:t>This matters. We can see every violation, but we never see the actual</a:t>
+              <a:t>Be honest about the data up front.</a:t>
             </a:r>
           </a:p>
         </p:txBody>
@@ -864,7 +1077,7 @@
           <a:lstStyle/>
           <a:p>
             <a:r>
-              <a:t>Two corrections drive everything. First, we don't trust the violation hour,</a:t>
+              <a:t>One pipeline, three layers.</a:t>
             </a:r>
           </a:p>
         </p:txBody>
@@ -934,7 +1147,7 @@
           <a:lstStyle/>
           <a:p>
             <a:r>
-              <a:t>We rank every cell on each of the four axes, then combine them. If the</a:t>
+              <a:t>The unglamorous work that makes the rest valid.</a:t>
             </a:r>
           </a:p>
         </p:txBody>
@@ -1004,7 +1217,7 @@
           <a:lstStyle/>
           <a:p>
             <a:r>
-              <a:t>This is where the idea lands. Same city, two colorings. Watch the</a:t>
+              <a:t>The heart of it. A cell must be bad on several axes to rank high.</a:t>
             </a:r>
           </a:p>
         </p:txBody>
@@ -1074,7 +1287,7 @@
           <a:lstStyle/>
           <a:p>
             <a:r>
-              <a:t>A map is nice, but an officer needs a list. So we hand them a shortlist with</a:t>
+              <a:t>The toggle is the wow moment. Demo it live.</a:t>
             </a:r>
           </a:p>
         </p:txBody>
@@ -1144,7 +1357,7 @@
           <a:lstStyle/>
           <a:p>
             <a:r>
-              <a:t>This is the supervised part, with real answers to check against.</a:t>
+              <a:t>A map is nice; an officer needs a list.</a:t>
             </a:r>
           </a:p>
         </p:txBody>
@@ -1214,7 +1427,7 @@
           <a:lstStyle/>
           <a:p>
             <a:r>
-              <a:t>Finally we make it actionable. Because the worst cells cluster, you don't</a:t>
+              <a:t>The persuasion slide. Lead with the night number.</a:t>
             </a:r>
           </a:p>
         </p:txBody>
@@ -1284,7 +1497,7 @@
           <a:lstStyle/>
           <a:p>
             <a:r>
-              <a:t>Three additions that turn the prioritisation into a business case and a</a:t>
+              <a:t>The number leadership remembers.</a:t>
             </a:r>
           </a:p>
         </p:txBody>
@@ -4310,6 +4523,7 @@
           <a:ln>
             <a:noFill/>
           </a:ln>
+          <a:effectLst/>
         </p:spPr>
         <p:style>
           <a:lnRef idx="1">
@@ -4341,8 +4555,8 @@
         </p:nvSpPr>
         <p:spPr>
           <a:xfrm>
-            <a:off x="822960" y="1920240"/>
-            <a:ext cx="10515600" cy="3200400"/>
+            <a:off x="822960" y="1828800"/>
+            <a:ext cx="10515600" cy="3291840"/>
           </a:xfrm>
           <a:prstGeom prst="rect">
             <a:avLst/>
@@ -4396,7 +4610,7 @@
               </a:defRPr>
             </a:pPr>
             <a:r>
-              <a:t>Gridlock Hackathon 2.0 (Flipkart), Round 2  |  Poor Visibility on Parking-Induced Congestion</a:t>
+              <a:t>Gridlock Hackathon 2.0 (Flipkart), Round 2   |   Poor Visibility on Parking-Induced Congestion</a:t>
             </a:r>
           </a:p>
           <a:p>
@@ -4411,7 +4625,7 @@
               </a:defRPr>
             </a:pPr>
             <a:r>
-              <a:t>Team Spectres  ·  Kavya Mahajan, Aarav Harshvardhan, Souhardyo Dasgupta, Vishesh Gupta</a:t>
+              <a:t>Team Spectres   ·   Kavya Mahajan, Aarav Harshvardhan, Souhardyo Dasgupta, Vishesh Gupta</a:t>
             </a:r>
           </a:p>
           <a:p>
@@ -4469,6 +4683,7 @@
           <a:ln>
             <a:noFill/>
           </a:ln>
+          <a:effectLst/>
         </p:spPr>
         <p:style>
           <a:lnRef idx="1">
@@ -4515,14 +4730,14 @@
           <a:lstStyle/>
           <a:p>
             <a:pPr>
-              <a:defRPr sz="3000" b="1">
+              <a:defRPr sz="2800" b="1">
                 <a:solidFill>
                   <a:srgbClr val="1B2A4A"/>
                 </a:solidFill>
               </a:defRPr>
             </a:pPr>
             <a:r>
-              <a:t>The cost, and two more models</a:t>
+              <a:t>What it costs</a:t>
             </a:r>
           </a:p>
         </p:txBody>
@@ -4535,8 +4750,8 @@
         </p:nvSpPr>
         <p:spPr>
           <a:xfrm>
-            <a:off x="640080" y="1554480"/>
-            <a:ext cx="6035040" cy="4754880"/>
+            <a:off x="640080" y="1508760"/>
+            <a:ext cx="10881360" cy="4937760"/>
           </a:xfrm>
           <a:prstGeom prst="rect">
             <a:avLst/>
@@ -4550,75 +4765,78 @@
           <a:lstStyle/>
           <a:p>
             <a:pPr>
+              <a:lnSpc>
+                <a:spcPct val="105000"/>
+              </a:lnSpc>
               <a:spcAft>
-                <a:spcPts val="1200"/>
+                <a:spcPts val="1000"/>
               </a:spcAft>
-              <a:defRPr sz="1900">
+              <a:defRPr sz="1700">
                 <a:solidFill>
                   <a:srgbClr val="1B2A4A"/>
                 </a:solidFill>
               </a:defRPr>
             </a:pPr>
             <a:r>
-              <a:t>•  The cost: the impact score becomes ~Rs 5.2 crore/year of delay (vehicle-hours, with a band); the worst 20 cells carry 31% of it.</a:t>
+              <a:t>•  Calibrate the physical delay-potential into vehicle-hours, then rupees, with a low / base / high band.</a:t>
             </a:r>
           </a:p>
           <a:p>
             <a:pPr>
+              <a:lnSpc>
+                <a:spcPct val="105000"/>
+              </a:lnSpc>
               <a:spcAft>
-                <a:spcPts val="1200"/>
+                <a:spcPts val="1000"/>
               </a:spcAft>
-              <a:defRPr sz="1900">
+              <a:defRPr sz="1700">
                 <a:solidFill>
                   <a:srgbClr val="1B2A4A"/>
                 </a:solidFill>
               </a:defRPr>
             </a:pPr>
             <a:r>
-              <a:t>•  Rising hotspots: 227 cells are escalating faster than the city, an early warning before they entrench.</a:t>
+              <a:t>•  About 574 vehicle-hours of delay per day; roughly Rs 5.2 crore per year (base case).</a:t>
             </a:r>
           </a:p>
           <a:p>
             <a:pPr>
+              <a:lnSpc>
+                <a:spcPct val="105000"/>
+              </a:lnSpc>
               <a:spcAft>
-                <a:spcPts val="1200"/>
+                <a:spcPts val="1000"/>
               </a:spcAft>
-              <a:defRPr sz="1900">
+              <a:defRPr sz="1700">
                 <a:solidFill>
                   <a:srgbClr val="1B2A4A"/>
                 </a:solidFill>
               </a:defRPr>
             </a:pPr>
             <a:r>
-              <a:t>•  False-report triage: a second model (ROC-AUC 0.758) flags likely-rejected reports; flag the top 20% and you catch 43% of them.</a:t>
-            </a:r>
-          </a:p>
-        </p:txBody>
-      </p:sp>
-      <p:pic>
-        <p:nvPicPr>
-          <p:cNvPr id="5" name="Picture 4" descr="fig-gap.png"/>
-          <p:cNvPicPr>
-            <a:picLocks noChangeAspect="1"/>
-          </p:cNvPicPr>
-          <p:nvPr/>
-        </p:nvPicPr>
-        <p:blipFill>
-          <a:blip r:embed="rId2"/>
-          <a:stretch>
-            <a:fillRect/>
-          </a:stretch>
-        </p:blipFill>
-        <p:spPr>
-          <a:xfrm>
-            <a:off x="6858000" y="1645920"/>
-            <a:ext cx="4846320" cy="3248005"/>
-          </a:xfrm>
-          <a:prstGeom prst="rect">
-            <a:avLst/>
-          </a:prstGeom>
-        </p:spPr>
-      </p:pic>
+              <a:t>•  The worst 20 cells carry 31% of the cost; just 58 cells carry half.</a:t>
+            </a:r>
+          </a:p>
+          <a:p>
+            <a:pPr>
+              <a:lnSpc>
+                <a:spcPct val="105000"/>
+              </a:lnSpc>
+              <a:spcAft>
+                <a:spcPts val="1000"/>
+              </a:spcAft>
+              <a:defRPr sz="1700">
+                <a:solidFill>
+                  <a:srgbClr val="1B2A4A"/>
+                </a:solidFill>
+              </a:defRPr>
+            </a:pPr>
+            <a:r>
+              <a:t>•  A first-order estimate, not a measurement. The relative concentration is robust to the assumptions.</a:t>
+            </a:r>
+          </a:p>
+        </p:txBody>
+      </p:sp>
     </p:spTree>
   </p:cSld>
   <p:clrMapOvr>
@@ -4657,6 +4875,7 @@
           <a:ln>
             <a:noFill/>
           </a:ln>
+          <a:effectLst/>
         </p:spPr>
         <p:style>
           <a:lnRef idx="1">
@@ -4703,14 +4922,14 @@
           <a:lstStyle/>
           <a:p>
             <a:pPr>
-              <a:defRPr sz="3000" b="1">
+              <a:defRPr sz="2800" b="1">
                 <a:solidFill>
                   <a:srgbClr val="1B2A4A"/>
                 </a:solidFill>
               </a:defRPr>
             </a:pPr>
             <a:r>
-              <a:t>Honest about the gap</a:t>
+              <a:t>Emerging hotspots: early warning</a:t>
             </a:r>
           </a:p>
         </p:txBody>
@@ -4723,8 +4942,8 @@
         </p:nvSpPr>
         <p:spPr>
           <a:xfrm>
-            <a:off x="640080" y="1554480"/>
-            <a:ext cx="6035040" cy="4754880"/>
+            <a:off x="640080" y="1508760"/>
+            <a:ext cx="10881360" cy="4937760"/>
           </a:xfrm>
           <a:prstGeom prst="rect">
             <a:avLst/>
@@ -4738,105 +4957,78 @@
           <a:lstStyle/>
           <a:p>
             <a:pPr>
+              <a:lnSpc>
+                <a:spcPct val="105000"/>
+              </a:lnSpc>
               <a:spcAft>
-                <a:spcPts val="1200"/>
+                <a:spcPts val="1000"/>
               </a:spcAft>
-              <a:defRPr sz="1900">
+              <a:defRPr sz="1700">
                 <a:solidFill>
                   <a:srgbClr val="1B2A4A"/>
                 </a:solidFill>
               </a:defRPr>
             </a:pPr>
             <a:r>
-              <a:t>•  No traffic speeds means the score is an estimate, not a measurement. We say so.</a:t>
+              <a:t>•  The score ranks where things are bad on average; this flags where they are getting WORSE.</a:t>
             </a:r>
           </a:p>
           <a:p>
             <a:pPr>
+              <a:lnSpc>
+                <a:spcPct val="105000"/>
+              </a:lnSpc>
               <a:spcAft>
-                <a:spcPts val="1200"/>
+                <a:spcPts val="1000"/>
               </a:spcAft>
-              <a:defRPr sz="1900">
+              <a:defRPr sz="1700">
                 <a:solidFill>
                   <a:srgbClr val="1B2A4A"/>
                 </a:solidFill>
               </a:defRPr>
             </a:pPr>
             <a:r>
-              <a:t>•  We validate by face validity (20 of the top 20 are known bad spots) and</a:t>
+              <a:t>•  Trend each cell's SHARE of citywide volume over the four full months, which detrends the citywide enforcement ramp.</a:t>
             </a:r>
           </a:p>
           <a:p>
             <a:pPr>
+              <a:lnSpc>
+                <a:spcPct val="105000"/>
+              </a:lnSpc>
               <a:spcAft>
-                <a:spcPts val="1200"/>
+                <a:spcPts val="1000"/>
               </a:spcAft>
-              <a:defRPr sz="1900">
+              <a:defRPr sz="1700">
                 <a:solidFill>
                   <a:srgbClr val="1B2A4A"/>
                 </a:solidFill>
               </a:defRPr>
             </a:pPr>
             <a:r>
-              <a:t>•  month-to-month stability (ρ ≈ 0.75).</a:t>
+              <a:t>•  227 cells are rising; 103 are both high-impact and rising, the priority set.</a:t>
             </a:r>
           </a:p>
           <a:p>
             <a:pPr>
+              <a:lnSpc>
+                <a:spcPct val="105000"/>
+              </a:lnSpc>
               <a:spcAft>
-                <a:spcPts val="1200"/>
+                <a:spcPts val="1000"/>
               </a:spcAft>
-              <a:defRPr sz="1900">
+              <a:defRPr sz="1700">
                 <a:solidFill>
                   <a:srgbClr val="1B2A4A"/>
                 </a:solidFill>
               </a:defRPr>
             </a:pPr>
             <a:r>
-              <a:t>•  Fusion-ready: the day a speed feed exists, it becomes the training target and the</a:t>
-            </a:r>
-          </a:p>
-          <a:p>
-            <a:pPr>
-              <a:spcAft>
-                <a:spcPts val="1200"/>
-              </a:spcAft>
-              <a:defRPr sz="1900">
-                <a:solidFill>
-                  <a:srgbClr val="1B2A4A"/>
-                </a:solidFill>
-              </a:defRPr>
-            </a:pPr>
-            <a:r>
-              <a:t>•  score becomes a learned model.</a:t>
-            </a:r>
-          </a:p>
-        </p:txBody>
-      </p:sp>
-      <p:pic>
-        <p:nvPicPr>
-          <p:cNvPr id="5" name="Picture 4" descr="fig-pipeline.png"/>
-          <p:cNvPicPr>
-            <a:picLocks noChangeAspect="1"/>
-          </p:cNvPicPr>
-          <p:nvPr/>
-        </p:nvPicPr>
-        <p:blipFill>
-          <a:blip r:embed="rId2"/>
-          <a:stretch>
-            <a:fillRect/>
-          </a:stretch>
-        </p:blipFill>
-        <p:spPr>
-          <a:xfrm>
-            <a:off x="6858000" y="1645920"/>
-            <a:ext cx="4846320" cy="2014762"/>
-          </a:xfrm>
-          <a:prstGeom prst="rect">
-            <a:avLst/>
-          </a:prstGeom>
-        </p:spPr>
-      </p:pic>
+              <a:t>•  Honest: a rising trend can reflect shifting enforcement focus, so we call it rising activity.</a:t>
+            </a:r>
+          </a:p>
+        </p:txBody>
+      </p:sp>
     </p:spTree>
   </p:cSld>
   <p:clrMapOvr>
@@ -4875,6 +5067,7 @@
           <a:ln>
             <a:noFill/>
           </a:ln>
+          <a:effectLst/>
         </p:spPr>
         <p:style>
           <a:lnRef idx="1">
@@ -4921,14 +5114,14 @@
           <a:lstStyle/>
           <a:p>
             <a:pPr>
-              <a:defRPr sz="3000" b="1">
+              <a:defRPr sz="2800" b="1">
                 <a:solidFill>
                   <a:srgbClr val="1B2A4A"/>
                 </a:solidFill>
               </a:defRPr>
             </a:pPr>
             <a:r>
-              <a:t>The product</a:t>
+              <a:t>Forecaster: the one model with real labels</a:t>
             </a:r>
           </a:p>
         </p:txBody>
@@ -4941,8 +5134,8 @@
         </p:nvSpPr>
         <p:spPr>
           <a:xfrm>
-            <a:off x="640080" y="1554480"/>
-            <a:ext cx="10789920" cy="4754880"/>
+            <a:off x="640080" y="1508760"/>
+            <a:ext cx="6126480" cy="4937760"/>
           </a:xfrm>
           <a:prstGeom prst="rect">
             <a:avLst/>
@@ -4956,51 +5149,102 @@
           <a:lstStyle/>
           <a:p>
             <a:pPr>
+              <a:lnSpc>
+                <a:spcPct val="105000"/>
+              </a:lnSpc>
               <a:spcAft>
-                <a:spcPts val="1200"/>
+                <a:spcPts val="1000"/>
               </a:spcAft>
-              <a:defRPr sz="1900">
+              <a:defRPr sz="1700">
                 <a:solidFill>
                   <a:srgbClr val="1B2A4A"/>
                 </a:solidFill>
               </a:defRPr>
             </a:pPr>
             <a:r>
-              <a:t>•  A fast, static web app: Next.js + deck.gl + Recharts.</a:t>
+              <a:t>•  Predict next-day violation intensity per cell on a strict temporal holdout (train Nov-Feb, test Mar-Apr).</a:t>
             </a:r>
           </a:p>
           <a:p>
             <a:pPr>
+              <a:lnSpc>
+                <a:spcPct val="105000"/>
+              </a:lnSpc>
               <a:spcAft>
-                <a:spcPts val="1200"/>
+                <a:spcPts val="1000"/>
               </a:spcAft>
-              <a:defRPr sz="1900">
+              <a:defRPr sz="1700">
                 <a:solidFill>
                   <a:srgbClr val="1B2A4A"/>
                 </a:solidFill>
               </a:defRPr>
             </a:pPr>
             <a:r>
-              <a:t>•  All compute is precomputed, so it runs on a CDN with no backend, no API keys.</a:t>
+              <a:t>•  A bake-off across the gradient-boosting family; LightGBM (Tweedie) wins.</a:t>
             </a:r>
           </a:p>
           <a:p>
             <a:pPr>
+              <a:lnSpc>
+                <a:spcPct val="105000"/>
+              </a:lnSpc>
               <a:spcAft>
-                <a:spcPts val="1200"/>
+                <a:spcPts val="1000"/>
               </a:spcAft>
-              <a:defRPr sz="1900">
+              <a:defRPr sz="1700">
                 <a:solidFill>
                   <a:srgbClr val="1B2A4A"/>
                 </a:solidFill>
               </a:defRPr>
             </a:pPr>
             <a:r>
-              <a:t>•  Scales to any traffic, costs almost nothing to host.</a:t>
-            </a:r>
-          </a:p>
-        </p:txBody>
-      </p:sp>
+              <a:t>•  Beats the seasonal-naive baseline by 36% on coverage@20; captures 72% of the oracle ceiling.</a:t>
+            </a:r>
+          </a:p>
+          <a:p>
+            <a:pPr>
+              <a:lnSpc>
+                <a:spcPct val="105000"/>
+              </a:lnSpc>
+              <a:spcAft>
+                <a:spcPts val="1000"/>
+              </a:spcAft>
+              <a:defRPr sz="1700">
+                <a:solidFill>
+                  <a:srgbClr val="1B2A4A"/>
+                </a:solidFill>
+              </a:defRPr>
+            </a:pPr>
+            <a:r>
+              <a:t>•  Honest ablation: 29 extra features and tuning did not beat the base set. The ceiling is the data, not the model.</a:t>
+            </a:r>
+          </a:p>
+        </p:txBody>
+      </p:sp>
+      <p:pic>
+        <p:nvPicPr>
+          <p:cNvPr id="5" name="Picture 4" descr="fig-forecast.png"/>
+          <p:cNvPicPr>
+            <a:picLocks noChangeAspect="1"/>
+          </p:cNvPicPr>
+          <p:nvPr/>
+        </p:nvPicPr>
+        <p:blipFill>
+          <a:blip r:embed="rId2"/>
+          <a:stretch>
+            <a:fillRect/>
+          </a:stretch>
+        </p:blipFill>
+        <p:spPr>
+          <a:xfrm>
+            <a:off x="6949440" y="1600200"/>
+            <a:ext cx="4754880" cy="2813914"/>
+          </a:xfrm>
+          <a:prstGeom prst="rect">
+            <a:avLst/>
+          </a:prstGeom>
+        </p:spPr>
+      </p:pic>
     </p:spTree>
   </p:cSld>
   <p:clrMapOvr>
@@ -5039,6 +5283,7 @@
           <a:ln>
             <a:noFill/>
           </a:ln>
+          <a:effectLst/>
         </p:spPr>
         <p:style>
           <a:lnRef idx="1">
@@ -5085,14 +5330,14 @@
           <a:lstStyle/>
           <a:p>
             <a:pPr>
-              <a:defRPr sz="3000" b="1">
+              <a:defRPr sz="2800" b="1">
                 <a:solidFill>
                   <a:srgbClr val="1B2A4A"/>
                 </a:solidFill>
               </a:defRPr>
             </a:pPr>
             <a:r>
-              <a:t>Impact and what's next</a:t>
+              <a:t>False-report triage: don't chase ghosts</a:t>
             </a:r>
           </a:p>
         </p:txBody>
@@ -5105,8 +5350,8 @@
         </p:nvSpPr>
         <p:spPr>
           <a:xfrm>
-            <a:off x="640080" y="1554480"/>
-            <a:ext cx="10789920" cy="4754880"/>
+            <a:off x="640080" y="1508760"/>
+            <a:ext cx="10881360" cy="4937760"/>
           </a:xfrm>
           <a:prstGeom prst="rect">
             <a:avLst/>
@@ -5120,47 +5365,674 @@
           <a:lstStyle/>
           <a:p>
             <a:pPr>
+              <a:lnSpc>
+                <a:spcPct val="105000"/>
+              </a:lnSpc>
               <a:spcAft>
-                <a:spcPts val="1200"/>
+                <a:spcPts val="1000"/>
               </a:spcAft>
-              <a:defRPr sz="1900">
+              <a:defRPr sz="1700">
                 <a:solidFill>
                   <a:srgbClr val="1B2A4A"/>
                 </a:solidFill>
               </a:defRPr>
             </a:pPr>
             <a:r>
-              <a:t>•  Today: turns a noisy violation feed into a ranked where-and-when for patrols.</a:t>
+              <a:t>•  About a third of reviewed reports are rejected on review.</a:t>
             </a:r>
           </a:p>
           <a:p>
             <a:pPr>
+              <a:lnSpc>
+                <a:spcPct val="105000"/>
+              </a:lnSpc>
               <a:spcAft>
-                <a:spcPts val="1200"/>
+                <a:spcPts val="1000"/>
               </a:spcAft>
-              <a:defRPr sz="1900">
+              <a:defRPr sz="1700">
                 <a:solidFill>
                   <a:srgbClr val="1B2A4A"/>
                 </a:solidFill>
               </a:defRPr>
             </a:pPr>
             <a:r>
-              <a:t>•  Next: plug in live speeds, an events calendar, and patrol rosters.</a:t>
+              <a:t>•  A separate supervised model predicts which, from the report's own attributes (location, time, vehicle, type).</a:t>
             </a:r>
           </a:p>
           <a:p>
             <a:pPr>
+              <a:lnSpc>
+                <a:spcPct val="105000"/>
+              </a:lnSpc>
               <a:spcAft>
-                <a:spcPts val="1200"/>
+                <a:spcPts val="1000"/>
               </a:spcAft>
-              <a:defRPr sz="1900">
+              <a:defRPr sz="1700">
                 <a:solidFill>
                   <a:srgbClr val="1B2A4A"/>
                 </a:solidFill>
               </a:defRPr>
             </a:pPr>
             <a:r>
-              <a:t>•  One sentence: send the next patrol where it relieves the most congestion.</a:t>
+              <a:t>•  ROC-AUC 0.758 on a stratified holdout: real structure, not a base rate.</a:t>
+            </a:r>
+          </a:p>
+          <a:p>
+            <a:pPr>
+              <a:lnSpc>
+                <a:spcPct val="105000"/>
+              </a:lnSpc>
+              <a:spcAft>
+                <a:spcPts val="1000"/>
+              </a:spcAft>
+              <a:defRPr sz="1700">
+                <a:solidFill>
+                  <a:srgbClr val="1B2A4A"/>
+                </a:solidFill>
+              </a:defRPr>
+            </a:pPr>
+            <a:r>
+              <a:t>•  Flag the top 20% most-suspect and you catch 43% of all rejections at 64% precision, so patrols go to real problems.</a:t>
+            </a:r>
+          </a:p>
+        </p:txBody>
+      </p:sp>
+    </p:spTree>
+  </p:cSld>
+  <p:clrMapOvr>
+    <a:masterClrMapping/>
+  </p:clrMapOvr>
+</p:sld>
+</file>
+
+<file path=ppt/slides/slide14.xml><?xml version="1.0" encoding="utf-8"?>
+<p:sld xmlns:a="http://schemas.openxmlformats.org/drawingml/2006/main" xmlns:p="http://schemas.openxmlformats.org/presentationml/2006/main" xmlns:r="http://schemas.openxmlformats.org/officeDocument/2006/relationships">
+  <p:cSld>
+    <p:spTree>
+      <p:nvGrpSpPr>
+        <p:cNvPr id="1" name=""/>
+        <p:cNvGrpSpPr/>
+        <p:nvPr/>
+      </p:nvGrpSpPr>
+      <p:grpSpPr/>
+      <p:sp>
+        <p:nvSpPr>
+          <p:cNvPr id="2" name="Rectangle 1"/>
+          <p:cNvSpPr/>
+          <p:nvPr/>
+        </p:nvSpPr>
+        <p:spPr>
+          <a:xfrm>
+            <a:off x="0" y="0"/>
+            <a:ext cx="12191695" cy="146304"/>
+          </a:xfrm>
+          <a:prstGeom prst="rect">
+            <a:avLst/>
+          </a:prstGeom>
+          <a:solidFill>
+            <a:srgbClr val="E4572E"/>
+          </a:solidFill>
+          <a:ln>
+            <a:noFill/>
+          </a:ln>
+          <a:effectLst/>
+        </p:spPr>
+        <p:style>
+          <a:lnRef idx="1">
+            <a:schemeClr val="accent1"/>
+          </a:lnRef>
+          <a:fillRef idx="3">
+            <a:schemeClr val="accent1"/>
+          </a:fillRef>
+          <a:effectRef idx="2">
+            <a:schemeClr val="accent1"/>
+          </a:effectRef>
+          <a:fontRef idx="minor">
+            <a:schemeClr val="lt1"/>
+          </a:fontRef>
+        </p:style>
+        <p:txBody>
+          <a:bodyPr rtlCol="0" anchor="ctr"/>
+          <a:lstStyle/>
+          <a:p>
+            <a:pPr algn="ctr"/>
+          </a:p>
+        </p:txBody>
+      </p:sp>
+      <p:sp>
+        <p:nvSpPr>
+          <p:cNvPr id="3" name="TextBox 2"/>
+          <p:cNvSpPr txBox="1"/>
+          <p:nvPr/>
+        </p:nvSpPr>
+        <p:spPr>
+          <a:xfrm>
+            <a:off x="548640" y="457200"/>
+            <a:ext cx="10972800" cy="914400"/>
+          </a:xfrm>
+          <a:prstGeom prst="rect">
+            <a:avLst/>
+          </a:prstGeom>
+          <a:noFill/>
+        </p:spPr>
+        <p:txBody>
+          <a:bodyPr wrap="square">
+            <a:spAutoFit/>
+          </a:bodyPr>
+          <a:lstStyle/>
+          <a:p>
+            <a:pPr>
+              <a:defRPr sz="2800" b="1">
+                <a:solidFill>
+                  <a:srgbClr val="1B2A4A"/>
+                </a:solidFill>
+              </a:defRPr>
+            </a:pPr>
+            <a:r>
+              <a:t>Patrol optimizer + ROI</a:t>
+            </a:r>
+          </a:p>
+        </p:txBody>
+      </p:sp>
+      <p:sp>
+        <p:nvSpPr>
+          <p:cNvPr id="4" name="TextBox 3"/>
+          <p:cNvSpPr txBox="1"/>
+          <p:nvPr/>
+        </p:nvSpPr>
+        <p:spPr>
+          <a:xfrm>
+            <a:off x="640080" y="1508760"/>
+            <a:ext cx="6126480" cy="4937760"/>
+          </a:xfrm>
+          <a:prstGeom prst="rect">
+            <a:avLst/>
+          </a:prstGeom>
+          <a:noFill/>
+        </p:spPr>
+        <p:txBody>
+          <a:bodyPr wrap="square">
+            <a:spAutoFit/>
+          </a:bodyPr>
+          <a:lstStyle/>
+          <a:p>
+            <a:pPr>
+              <a:lnSpc>
+                <a:spcPct val="105000"/>
+              </a:lnSpc>
+              <a:spcAft>
+                <a:spcPts val="1000"/>
+              </a:spcAft>
+              <a:defRPr sz="1700">
+                <a:solidFill>
+                  <a:srgbClr val="1B2A4A"/>
+                </a:solidFill>
+              </a:defRPr>
+            </a:pPr>
+            <a:r>
+              <a:t>•  A greedy max-coverage optimizer assigns N beats (a cell plus its H3 ring) to maximize impact covered.</a:t>
+            </a:r>
+          </a:p>
+          <a:p>
+            <a:pPr>
+              <a:lnSpc>
+                <a:spcPct val="105000"/>
+              </a:lnSpc>
+              <a:spcAft>
+                <a:spcPts val="1000"/>
+              </a:spcAft>
+              <a:defRPr sz="1700">
+                <a:solidFill>
+                  <a:srgbClr val="1B2A4A"/>
+                </a:solidFill>
+              </a:defRPr>
+            </a:pPr>
+            <a:r>
+              <a:t>•  Because the worst cells cluster, 20 beats cover 53% of citywide impact vs 47% for a naive top-N pick.</a:t>
+            </a:r>
+          </a:p>
+          <a:p>
+            <a:pPr>
+              <a:lnSpc>
+                <a:spcPct val="105000"/>
+              </a:lnSpc>
+              <a:spcAft>
+                <a:spcPts val="1000"/>
+              </a:spcAft>
+              <a:defRPr sz="1700">
+                <a:solidFill>
+                  <a:srgbClr val="1B2A4A"/>
+                </a:solidFill>
+              </a:defRPr>
+            </a:pPr>
+            <a:r>
+              <a:t>•  The slider also reports the rupee ROI: 20 patrols relieve roughly Rs 77k per day of delay.</a:t>
+            </a:r>
+          </a:p>
+          <a:p>
+            <a:pPr>
+              <a:lnSpc>
+                <a:spcPct val="105000"/>
+              </a:lnSpc>
+              <a:spcAft>
+                <a:spcPts val="1000"/>
+              </a:spcAft>
+              <a:defRPr sz="1700">
+                <a:solidFill>
+                  <a:srgbClr val="1B2A4A"/>
+                </a:solidFill>
+              </a:defRPr>
+            </a:pPr>
+            <a:r>
+              <a:t>•  Same fleet, more relief. It turns the analysis into a deployable plan with a number attached.</a:t>
+            </a:r>
+          </a:p>
+        </p:txBody>
+      </p:sp>
+      <p:pic>
+        <p:nvPicPr>
+          <p:cNvPr id="5" name="Picture 4" descr="fig-coverage.png"/>
+          <p:cNvPicPr>
+            <a:picLocks noChangeAspect="1"/>
+          </p:cNvPicPr>
+          <p:nvPr/>
+        </p:nvPicPr>
+        <p:blipFill>
+          <a:blip r:embed="rId2"/>
+          <a:stretch>
+            <a:fillRect/>
+          </a:stretch>
+        </p:blipFill>
+        <p:spPr>
+          <a:xfrm>
+            <a:off x="6949440" y="1600200"/>
+            <a:ext cx="4754880" cy="3242727"/>
+          </a:xfrm>
+          <a:prstGeom prst="rect">
+            <a:avLst/>
+          </a:prstGeom>
+        </p:spPr>
+      </p:pic>
+    </p:spTree>
+  </p:cSld>
+  <p:clrMapOvr>
+    <a:masterClrMapping/>
+  </p:clrMapOvr>
+</p:sld>
+</file>
+
+<file path=ppt/slides/slide15.xml><?xml version="1.0" encoding="utf-8"?>
+<p:sld xmlns:a="http://schemas.openxmlformats.org/drawingml/2006/main" xmlns:p="http://schemas.openxmlformats.org/presentationml/2006/main" xmlns:r="http://schemas.openxmlformats.org/officeDocument/2006/relationships">
+  <p:cSld>
+    <p:spTree>
+      <p:nvGrpSpPr>
+        <p:cNvPr id="1" name=""/>
+        <p:cNvGrpSpPr/>
+        <p:nvPr/>
+      </p:nvGrpSpPr>
+      <p:grpSpPr/>
+      <p:sp>
+        <p:nvSpPr>
+          <p:cNvPr id="2" name="Rectangle 1"/>
+          <p:cNvSpPr/>
+          <p:nvPr/>
+        </p:nvSpPr>
+        <p:spPr>
+          <a:xfrm>
+            <a:off x="0" y="0"/>
+            <a:ext cx="12191695" cy="146304"/>
+          </a:xfrm>
+          <a:prstGeom prst="rect">
+            <a:avLst/>
+          </a:prstGeom>
+          <a:solidFill>
+            <a:srgbClr val="E4572E"/>
+          </a:solidFill>
+          <a:ln>
+            <a:noFill/>
+          </a:ln>
+          <a:effectLst/>
+        </p:spPr>
+        <p:style>
+          <a:lnRef idx="1">
+            <a:schemeClr val="accent1"/>
+          </a:lnRef>
+          <a:fillRef idx="3">
+            <a:schemeClr val="accent1"/>
+          </a:fillRef>
+          <a:effectRef idx="2">
+            <a:schemeClr val="accent1"/>
+          </a:effectRef>
+          <a:fontRef idx="minor">
+            <a:schemeClr val="lt1"/>
+          </a:fontRef>
+        </p:style>
+        <p:txBody>
+          <a:bodyPr rtlCol="0" anchor="ctr"/>
+          <a:lstStyle/>
+          <a:p>
+            <a:pPr algn="ctr"/>
+          </a:p>
+        </p:txBody>
+      </p:sp>
+      <p:sp>
+        <p:nvSpPr>
+          <p:cNvPr id="3" name="TextBox 2"/>
+          <p:cNvSpPr txBox="1"/>
+          <p:nvPr/>
+        </p:nvSpPr>
+        <p:spPr>
+          <a:xfrm>
+            <a:off x="548640" y="457200"/>
+            <a:ext cx="10972800" cy="914400"/>
+          </a:xfrm>
+          <a:prstGeom prst="rect">
+            <a:avLst/>
+          </a:prstGeom>
+          <a:noFill/>
+        </p:spPr>
+        <p:txBody>
+          <a:bodyPr wrap="square">
+            <a:spAutoFit/>
+          </a:bodyPr>
+          <a:lstStyle/>
+          <a:p>
+            <a:pPr>
+              <a:defRPr sz="2800" b="1">
+                <a:solidFill>
+                  <a:srgbClr val="1B2A4A"/>
+                </a:solidFill>
+              </a:defRPr>
+            </a:pPr>
+            <a:r>
+              <a:t>Honest about the gap</a:t>
+            </a:r>
+          </a:p>
+        </p:txBody>
+      </p:sp>
+      <p:sp>
+        <p:nvSpPr>
+          <p:cNvPr id="4" name="TextBox 3"/>
+          <p:cNvSpPr txBox="1"/>
+          <p:nvPr/>
+        </p:nvSpPr>
+        <p:spPr>
+          <a:xfrm>
+            <a:off x="640080" y="1508760"/>
+            <a:ext cx="10881360" cy="4937760"/>
+          </a:xfrm>
+          <a:prstGeom prst="rect">
+            <a:avLst/>
+          </a:prstGeom>
+          <a:noFill/>
+        </p:spPr>
+        <p:txBody>
+          <a:bodyPr wrap="square">
+            <a:spAutoFit/>
+          </a:bodyPr>
+          <a:lstStyle/>
+          <a:p>
+            <a:pPr>
+              <a:lnSpc>
+                <a:spcPct val="105000"/>
+              </a:lnSpc>
+              <a:spcAft>
+                <a:spcPts val="1000"/>
+              </a:spcAft>
+              <a:defRPr sz="1700">
+                <a:solidFill>
+                  <a:srgbClr val="1B2A4A"/>
+                </a:solidFill>
+              </a:defRPr>
+            </a:pPr>
+            <a:r>
+              <a:t>•  No ground truth for impact: the score is an engineered index, validated by face validity and stability, never claimed as accuracy.</a:t>
+            </a:r>
+          </a:p>
+          <a:p>
+            <a:pPr>
+              <a:lnSpc>
+                <a:spcPct val="105000"/>
+              </a:lnSpc>
+              <a:spcAft>
+                <a:spcPts val="1000"/>
+              </a:spcAft>
+              <a:defRPr sz="1700">
+                <a:solidFill>
+                  <a:srgbClr val="1B2A4A"/>
+                </a:solidFill>
+              </a:defRPr>
+            </a:pPr>
+            <a:r>
+              <a:t>•  The enforcement confound: we weight by exogenous exposure, never the recorded hour.</a:t>
+            </a:r>
+          </a:p>
+          <a:p>
+            <a:pPr>
+              <a:lnSpc>
+                <a:spcPct val="105000"/>
+              </a:lnSpc>
+              <a:spcAft>
+                <a:spcPts val="1000"/>
+              </a:spcAft>
+              <a:defRPr sz="1700">
+                <a:solidFill>
+                  <a:srgbClr val="1B2A4A"/>
+                </a:solidFill>
+              </a:defRPr>
+            </a:pPr>
+            <a:r>
+              <a:t>•  The data can't see the evening (enforcement rarely works evenings), so we don't fake an hour-by-hour schedule.</a:t>
+            </a:r>
+          </a:p>
+          <a:p>
+            <a:pPr>
+              <a:lnSpc>
+                <a:spcPct val="105000"/>
+              </a:lnSpc>
+              <a:spcAft>
+                <a:spcPts val="1000"/>
+              </a:spcAft>
+              <a:defRPr sz="1700">
+                <a:solidFill>
+                  <a:srgbClr val="1B2A4A"/>
+                </a:solidFill>
+              </a:defRPr>
+            </a:pPr>
+            <a:r>
+              <a:t>•  Fusion-ready: a live speed feed turns the index into a learning model, with measured slowdown as the label.</a:t>
+            </a:r>
+          </a:p>
+        </p:txBody>
+      </p:sp>
+    </p:spTree>
+  </p:cSld>
+  <p:clrMapOvr>
+    <a:masterClrMapping/>
+  </p:clrMapOvr>
+</p:sld>
+</file>
+
+<file path=ppt/slides/slide16.xml><?xml version="1.0" encoding="utf-8"?>
+<p:sld xmlns:a="http://schemas.openxmlformats.org/drawingml/2006/main" xmlns:p="http://schemas.openxmlformats.org/presentationml/2006/main" xmlns:r="http://schemas.openxmlformats.org/officeDocument/2006/relationships">
+  <p:cSld>
+    <p:spTree>
+      <p:nvGrpSpPr>
+        <p:cNvPr id="1" name=""/>
+        <p:cNvGrpSpPr/>
+        <p:nvPr/>
+      </p:nvGrpSpPr>
+      <p:grpSpPr/>
+      <p:sp>
+        <p:nvSpPr>
+          <p:cNvPr id="2" name="Rectangle 1"/>
+          <p:cNvSpPr/>
+          <p:nvPr/>
+        </p:nvSpPr>
+        <p:spPr>
+          <a:xfrm>
+            <a:off x="0" y="0"/>
+            <a:ext cx="12191695" cy="146304"/>
+          </a:xfrm>
+          <a:prstGeom prst="rect">
+            <a:avLst/>
+          </a:prstGeom>
+          <a:solidFill>
+            <a:srgbClr val="E4572E"/>
+          </a:solidFill>
+          <a:ln>
+            <a:noFill/>
+          </a:ln>
+          <a:effectLst/>
+        </p:spPr>
+        <p:style>
+          <a:lnRef idx="1">
+            <a:schemeClr val="accent1"/>
+          </a:lnRef>
+          <a:fillRef idx="3">
+            <a:schemeClr val="accent1"/>
+          </a:fillRef>
+          <a:effectRef idx="2">
+            <a:schemeClr val="accent1"/>
+          </a:effectRef>
+          <a:fontRef idx="minor">
+            <a:schemeClr val="lt1"/>
+          </a:fontRef>
+        </p:style>
+        <p:txBody>
+          <a:bodyPr rtlCol="0" anchor="ctr"/>
+          <a:lstStyle/>
+          <a:p>
+            <a:pPr algn="ctr"/>
+          </a:p>
+        </p:txBody>
+      </p:sp>
+      <p:sp>
+        <p:nvSpPr>
+          <p:cNvPr id="3" name="TextBox 2"/>
+          <p:cNvSpPr txBox="1"/>
+          <p:nvPr/>
+        </p:nvSpPr>
+        <p:spPr>
+          <a:xfrm>
+            <a:off x="548640" y="457200"/>
+            <a:ext cx="10972800" cy="914400"/>
+          </a:xfrm>
+          <a:prstGeom prst="rect">
+            <a:avLst/>
+          </a:prstGeom>
+          <a:noFill/>
+        </p:spPr>
+        <p:txBody>
+          <a:bodyPr wrap="square">
+            <a:spAutoFit/>
+          </a:bodyPr>
+          <a:lstStyle/>
+          <a:p>
+            <a:pPr>
+              <a:defRPr sz="2800" b="1">
+                <a:solidFill>
+                  <a:srgbClr val="1B2A4A"/>
+                </a:solidFill>
+              </a:defRPr>
+            </a:pPr>
+            <a:r>
+              <a:t>Tech, impact, and what's next</a:t>
+            </a:r>
+          </a:p>
+        </p:txBody>
+      </p:sp>
+      <p:sp>
+        <p:nvSpPr>
+          <p:cNvPr id="4" name="TextBox 3"/>
+          <p:cNvSpPr txBox="1"/>
+          <p:nvPr/>
+        </p:nvSpPr>
+        <p:spPr>
+          <a:xfrm>
+            <a:off x="640080" y="1508760"/>
+            <a:ext cx="10881360" cy="4937760"/>
+          </a:xfrm>
+          <a:prstGeom prst="rect">
+            <a:avLst/>
+          </a:prstGeom>
+          <a:noFill/>
+        </p:spPr>
+        <p:txBody>
+          <a:bodyPr wrap="square">
+            <a:spAutoFit/>
+          </a:bodyPr>
+          <a:lstStyle/>
+          <a:p>
+            <a:pPr>
+              <a:lnSpc>
+                <a:spcPct val="105000"/>
+              </a:lnSpc>
+              <a:spcAft>
+                <a:spcPts val="1000"/>
+              </a:spcAft>
+              <a:defRPr sz="1700">
+                <a:solidFill>
+                  <a:srgbClr val="1B2A4A"/>
+                </a:solidFill>
+              </a:defRPr>
+            </a:pPr>
+            <a:r>
+              <a:t>•  Pipeline: Python (pandas, h3, scikit-learn, lightgbm). App: Next.js + deck.gl, fully static, on a CDN with no backend or API keys.</a:t>
+            </a:r>
+          </a:p>
+          <a:p>
+            <a:pPr>
+              <a:lnSpc>
+                <a:spcPct val="105000"/>
+              </a:lnSpc>
+              <a:spcAft>
+                <a:spcPts val="1000"/>
+              </a:spcAft>
+              <a:defRPr sz="1700">
+                <a:solidFill>
+                  <a:srgbClr val="1B2A4A"/>
+                </a:solidFill>
+              </a:defRPr>
+            </a:pPr>
+            <a:r>
+              <a:t>•  Live demo: https://flipkart-gridlock-gamma.vercel.app/</a:t>
+            </a:r>
+          </a:p>
+          <a:p>
+            <a:pPr>
+              <a:lnSpc>
+                <a:spcPct val="105000"/>
+              </a:lnSpc>
+              <a:spcAft>
+                <a:spcPts val="1000"/>
+              </a:spcAft>
+              <a:defRPr sz="1700">
+                <a:solidFill>
+                  <a:srgbClr val="1B2A4A"/>
+                </a:solidFill>
+              </a:defRPr>
+            </a:pPr>
+            <a:r>
+              <a:t>•  Impact today: a ranked, costed, where-and-when patrol plan with its ROI.</a:t>
+            </a:r>
+          </a:p>
+          <a:p>
+            <a:pPr>
+              <a:lnSpc>
+                <a:spcPct val="105000"/>
+              </a:lnSpc>
+              <a:spcAft>
+                <a:spcPts val="1000"/>
+              </a:spcAft>
+              <a:defRPr sz="1700">
+                <a:solidFill>
+                  <a:srgbClr val="1B2A4A"/>
+                </a:solidFill>
+              </a:defRPr>
+            </a:pPr>
+            <a:r>
+              <a:t>•  Next: plug in live speeds (a true impact label), the OSM road graph (flow-criticality), and patrol rosters (de-bias the confound).</a:t>
             </a:r>
           </a:p>
         </p:txBody>
@@ -5203,6 +6075,7 @@
           <a:ln>
             <a:noFill/>
           </a:ln>
+          <a:effectLst/>
         </p:spPr>
         <p:style>
           <a:lnRef idx="1">
@@ -5249,7 +6122,7 @@
           <a:lstStyle/>
           <a:p>
             <a:pPr>
-              <a:defRPr sz="3000" b="1">
+              <a:defRPr sz="2800" b="1">
                 <a:solidFill>
                   <a:srgbClr val="1B2A4A"/>
                 </a:solidFill>
@@ -5269,8 +6142,8 @@
         </p:nvSpPr>
         <p:spPr>
           <a:xfrm>
-            <a:off x="640080" y="1554480"/>
-            <a:ext cx="10789920" cy="4754880"/>
+            <a:off x="640080" y="1508760"/>
+            <a:ext cx="10881360" cy="4937760"/>
           </a:xfrm>
           <a:prstGeom prst="rect">
             <a:avLst/>
@@ -5284,47 +6157,74 @@
           <a:lstStyle/>
           <a:p>
             <a:pPr>
+              <a:lnSpc>
+                <a:spcPct val="105000"/>
+              </a:lnSpc>
               <a:spcAft>
-                <a:spcPts val="1200"/>
+                <a:spcPts val="1000"/>
               </a:spcAft>
-              <a:defRPr sz="1900">
+              <a:defRPr sz="1700">
                 <a:solidFill>
                   <a:srgbClr val="1B2A4A"/>
                 </a:solidFill>
               </a:defRPr>
             </a:pPr>
             <a:r>
-              <a:t>•  Bengaluru logs thousands of parking violations every day.</a:t>
+              <a:t>•  Bengaluru logs thousands of parking violations a day, but the feed shows where TICKETS are written, not where parking actually blocks traffic.</a:t>
             </a:r>
           </a:p>
           <a:p>
             <a:pPr>
+              <a:lnSpc>
+                <a:spcPct val="105000"/>
+              </a:lnSpc>
               <a:spcAft>
-                <a:spcPts val="1200"/>
+                <a:spcPts val="1000"/>
               </a:spcAft>
-              <a:defRPr sz="1900">
+              <a:defRPr sz="1700">
                 <a:solidFill>
                   <a:srgbClr val="1B2A4A"/>
                 </a:solidFill>
               </a:defRPr>
             </a:pPr>
             <a:r>
-              <a:t>•  But the feed shows where tickets get written, not where parking blocks traffic.</a:t>
+              <a:t>•  Those are different places: a lane that catches a daily pre-dawn sweep can out-ticket the junction that jams a main road every evening.</a:t>
             </a:r>
           </a:p>
           <a:p>
             <a:pPr>
+              <a:lnSpc>
+                <a:spcPct val="105000"/>
+              </a:lnSpc>
               <a:spcAft>
-                <a:spcPts val="1200"/>
+                <a:spcPts val="1000"/>
               </a:spcAft>
-              <a:defRPr sz="1900">
+              <a:defRPr sz="1700">
                 <a:solidFill>
                   <a:srgbClr val="1B2A4A"/>
                 </a:solidFill>
               </a:defRPr>
             </a:pPr>
             <a:r>
-              <a:t>•  Those are not the same place.</a:t>
+              <a:t>•  Enforcement is reactive and patrol-based, with no impact heatmap and no way to prioritize.</a:t>
+            </a:r>
+          </a:p>
+          <a:p>
+            <a:pPr>
+              <a:lnSpc>
+                <a:spcPct val="105000"/>
+              </a:lnSpc>
+              <a:spcAft>
+                <a:spcPts val="1000"/>
+              </a:spcAft>
+              <a:defRPr sz="1700">
+                <a:solidFill>
+                  <a:srgbClr val="1B2A4A"/>
+                </a:solidFill>
+              </a:defRPr>
+            </a:pPr>
+            <a:r>
+              <a:t>•  Goal: tell an officer where, when, and at what cost to deploy, and how many patrols it takes.</a:t>
             </a:r>
           </a:p>
         </p:txBody>
@@ -5367,6 +6267,7 @@
           <a:ln>
             <a:noFill/>
           </a:ln>
+          <a:effectLst/>
         </p:spPr>
         <p:style>
           <a:lnRef idx="1">
@@ -5413,14 +6314,14 @@
           <a:lstStyle/>
           <a:p>
             <a:pPr>
-              <a:defRPr sz="3000" b="1">
+              <a:defRPr sz="2800" b="1">
                 <a:solidFill>
                   <a:srgbClr val="1B2A4A"/>
                 </a:solidFill>
               </a:defRPr>
             </a:pPr>
             <a:r>
-              <a:t>What we had to work with</a:t>
+              <a:t>The data we have (and don't)</a:t>
             </a:r>
           </a:p>
         </p:txBody>
@@ -5433,8 +6334,8 @@
         </p:nvSpPr>
         <p:spPr>
           <a:xfrm>
-            <a:off x="640080" y="1554480"/>
-            <a:ext cx="10789920" cy="4754880"/>
+            <a:off x="640080" y="1508760"/>
+            <a:ext cx="10881360" cy="4937760"/>
           </a:xfrm>
           <a:prstGeom prst="rect">
             <a:avLst/>
@@ -5448,47 +6349,92 @@
           <a:lstStyle/>
           <a:p>
             <a:pPr>
+              <a:lnSpc>
+                <a:spcPct val="105000"/>
+              </a:lnSpc>
               <a:spcAft>
-                <a:spcPts val="1200"/>
+                <a:spcPts val="1000"/>
               </a:spcAft>
-              <a:defRPr sz="1900">
+              <a:defRPr sz="1500">
                 <a:solidFill>
                   <a:srgbClr val="1B2A4A"/>
                 </a:solidFill>
               </a:defRPr>
             </a:pPr>
             <a:r>
-              <a:t>•  298,445 real violation records, five months, the whole city.</a:t>
+              <a:t>•  298,445 real violation records, 151 days (Nov 2023 to Apr 2024), 54 police stations.</a:t>
             </a:r>
           </a:p>
           <a:p>
             <a:pPr>
+              <a:lnSpc>
+                <a:spcPct val="105000"/>
+              </a:lnSpc>
               <a:spcAft>
-                <a:spcPts val="1200"/>
+                <a:spcPts val="1000"/>
               </a:spcAft>
-              <a:defRPr sz="1900">
+              <a:defRPr sz="1500">
                 <a:solidFill>
                   <a:srgbClr val="1B2A4A"/>
                 </a:solidFill>
               </a:defRPr>
             </a:pPr>
             <a:r>
-              <a:t>•  Rich detail: location, vehicle, violation type, timestamps.</a:t>
+              <a:t>•  Per record: location, violation type, vehicle type, timestamps.</a:t>
             </a:r>
           </a:p>
           <a:p>
             <a:pPr>
+              <a:lnSpc>
+                <a:spcPct val="105000"/>
+              </a:lnSpc>
               <a:spcAft>
-                <a:spcPts val="1200"/>
+                <a:spcPts val="1000"/>
               </a:spcAft>
-              <a:defRPr sz="1900">
+              <a:defRPr sz="1500">
                 <a:solidFill>
                   <a:srgbClr val="1B2A4A"/>
                 </a:solidFill>
               </a:defRPr>
             </a:pPr>
             <a:r>
-              <a:t>•  One thing missing: no traffic speeds, anywhere in the data.</a:t>
+              <a:t>•  Missing: no traffic speeds, volumes, or travel times, so congestion impact must be DERIVED, not looked up.</a:t>
+            </a:r>
+          </a:p>
+          <a:p>
+            <a:pPr>
+              <a:lnSpc>
+                <a:spcPct val="105000"/>
+              </a:lnSpc>
+              <a:spcAft>
+                <a:spcPts val="1000"/>
+              </a:spcAft>
+              <a:defRPr sz="1500">
+                <a:solidFill>
+                  <a:srgbClr val="1B2A4A"/>
+                </a:solidFill>
+              </a:defRPr>
+            </a:pPr>
+            <a:r>
+              <a:t>•  Confound: a violation is logged only when a patrol is present. A daily 4-5am sweep is 15% of all records.</a:t>
+            </a:r>
+          </a:p>
+          <a:p>
+            <a:pPr>
+              <a:lnSpc>
+                <a:spcPct val="105000"/>
+              </a:lnSpc>
+              <a:spcAft>
+                <a:spcPts val="1000"/>
+              </a:spcAft>
+              <a:defRPr sz="1500">
+                <a:solidFill>
+                  <a:srgbClr val="1B2A4A"/>
+                </a:solidFill>
+              </a:defRPr>
+            </a:pPr>
+            <a:r>
+              <a:t>•  So recorded violations are roughly parking demand times patrol presence, and the recorded hour reflects shifts, not congestion.</a:t>
             </a:r>
           </a:p>
         </p:txBody>
@@ -5531,6 +6477,7 @@
           <a:ln>
             <a:noFill/>
           </a:ln>
+          <a:effectLst/>
         </p:spPr>
         <p:style>
           <a:lnRef idx="1">
@@ -5577,14 +6524,14 @@
           <a:lstStyle/>
           <a:p>
             <a:pPr>
-              <a:defRPr sz="3000" b="1">
+              <a:defRPr sz="2800" b="1">
                 <a:solidFill>
                   <a:srgbClr val="1B2A4A"/>
                 </a:solidFill>
               </a:defRPr>
             </a:pPr>
             <a:r>
-              <a:t>The insight</a:t>
+              <a:t>Our approach: see, understand, act</a:t>
             </a:r>
           </a:p>
         </p:txBody>
@@ -5597,8 +6544,8 @@
         </p:nvSpPr>
         <p:spPr>
           <a:xfrm>
-            <a:off x="640080" y="1554480"/>
-            <a:ext cx="10789920" cy="4754880"/>
+            <a:off x="640080" y="1508760"/>
+            <a:ext cx="6126480" cy="4937760"/>
           </a:xfrm>
           <a:prstGeom prst="rect">
             <a:avLst/>
@@ -5612,66 +6559,102 @@
           <a:lstStyle/>
           <a:p>
             <a:pPr>
+              <a:lnSpc>
+                <a:spcPct val="105000"/>
+              </a:lnSpc>
               <a:spcAft>
-                <a:spcPts val="1200"/>
+                <a:spcPts val="1000"/>
               </a:spcAft>
-              <a:defRPr sz="1900">
+              <a:defRPr sz="1700">
                 <a:solidFill>
                   <a:srgbClr val="1B2A4A"/>
                 </a:solidFill>
               </a:defRPr>
             </a:pPr>
             <a:r>
-              <a:t>•  A raw violation count is mostly "where patrols happen to be."</a:t>
+              <a:t>•  SEE: an impact-weighted hotspot map and a ranked shortlist of zones.</a:t>
             </a:r>
           </a:p>
           <a:p>
             <a:pPr>
+              <a:lnSpc>
+                <a:spcPct val="105000"/>
+              </a:lnSpc>
               <a:spcAft>
-                <a:spcPts val="1200"/>
+                <a:spcPts val="1000"/>
               </a:spcAft>
-              <a:defRPr sz="1900">
+              <a:defRPr sz="1700">
                 <a:solidFill>
                   <a:srgbClr val="1B2A4A"/>
                 </a:solidFill>
               </a:defRPr>
             </a:pPr>
             <a:r>
-              <a:t>•  A daily 4–5am sweep alone is 15% of all records.</a:t>
+              <a:t>•  UNDERSTAND: what the congestion costs, where effort is misallocated, which spots are worsening.</a:t>
             </a:r>
           </a:p>
           <a:p>
             <a:pPr>
+              <a:lnSpc>
+                <a:spcPct val="105000"/>
+              </a:lnSpc>
               <a:spcAft>
-                <a:spcPts val="1200"/>
+                <a:spcPts val="1000"/>
               </a:spcAft>
-              <a:defRPr sz="1900">
+              <a:defRPr sz="1700">
                 <a:solidFill>
                   <a:srgbClr val="1B2A4A"/>
                 </a:solidFill>
               </a:defRPr>
             </a:pPr>
             <a:r>
-              <a:t>•  Real impact depends on how much a violation blocks a busy road, and how</a:t>
+              <a:t>•  ACT: a forecaster, a false-report triage model, and a patrol optimizer that outputs a costed plan.</a:t>
             </a:r>
           </a:p>
           <a:p>
             <a:pPr>
+              <a:lnSpc>
+                <a:spcPct val="105000"/>
+              </a:lnSpc>
               <a:spcAft>
-                <a:spcPts val="1200"/>
+                <a:spcPts val="1000"/>
               </a:spcAft>
-              <a:defRPr sz="1900">
+              <a:defRPr sz="1700">
                 <a:solidFill>
                   <a:srgbClr val="1B2A4A"/>
                 </a:solidFill>
               </a:defRPr>
             </a:pPr>
             <a:r>
-              <a:t>•  often the same spot reoffends.</a:t>
-            </a:r>
-          </a:p>
-        </p:txBody>
-      </p:sp>
+              <a:t>•  Runs on the cleaned data with no live feed, and is built to absorb one when it exists.</a:t>
+            </a:r>
+          </a:p>
+        </p:txBody>
+      </p:sp>
+      <p:pic>
+        <p:nvPicPr>
+          <p:cNvPr id="5" name="Picture 4" descr="fig-pipeline.png"/>
+          <p:cNvPicPr>
+            <a:picLocks noChangeAspect="1"/>
+          </p:cNvPicPr>
+          <p:nvPr/>
+        </p:nvPicPr>
+        <p:blipFill>
+          <a:blip r:embed="rId2"/>
+          <a:stretch>
+            <a:fillRect/>
+          </a:stretch>
+        </p:blipFill>
+        <p:spPr>
+          <a:xfrm>
+            <a:off x="6949440" y="1600200"/>
+            <a:ext cx="4754880" cy="1976748"/>
+          </a:xfrm>
+          <a:prstGeom prst="rect">
+            <a:avLst/>
+          </a:prstGeom>
+        </p:spPr>
+      </p:pic>
     </p:spTree>
   </p:cSld>
   <p:clrMapOvr>
@@ -5710,6 +6693,7 @@
           <a:ln>
             <a:noFill/>
           </a:ln>
+          <a:effectLst/>
         </p:spPr>
         <p:style>
           <a:lnRef idx="1">
@@ -5756,14 +6740,14 @@
           <a:lstStyle/>
           <a:p>
             <a:pPr>
-              <a:defRPr sz="3000" b="1">
+              <a:defRPr sz="2800" b="1">
                 <a:solidFill>
                   <a:srgbClr val="1B2A4A"/>
                 </a:solidFill>
               </a:defRPr>
             </a:pPr>
             <a:r>
-              <a:t>The Congestion Impact Score</a:t>
+              <a:t>How we build it: data foundation</a:t>
             </a:r>
           </a:p>
         </p:txBody>
@@ -5776,8 +6760,8 @@
         </p:nvSpPr>
         <p:spPr>
           <a:xfrm>
-            <a:off x="640080" y="1554480"/>
-            <a:ext cx="6035040" cy="4754880"/>
+            <a:off x="640080" y="1508760"/>
+            <a:ext cx="10881360" cy="4937760"/>
           </a:xfrm>
           <a:prstGeom prst="rect">
             <a:avLst/>
@@ -5791,75 +6775,96 @@
           <a:lstStyle/>
           <a:p>
             <a:pPr>
+              <a:lnSpc>
+                <a:spcPct val="105000"/>
+              </a:lnSpc>
               <a:spcAft>
-                <a:spcPts val="1200"/>
+                <a:spcPts val="1000"/>
               </a:spcAft>
-              <a:defRPr sz="1900">
+              <a:defRPr sz="1500">
                 <a:solidFill>
                   <a:srgbClr val="1B2A4A"/>
                 </a:solidFill>
               </a:defRPr>
             </a:pPr>
             <a:r>
-              <a:t>•  One score, 0 to 100, per cell (~150 m).</a:t>
+              <a:t>•  Convert timestamps UTC to IST. Without this, rush-hour analysis is 5.5 hours wrong.</a:t>
             </a:r>
           </a:p>
           <a:p>
             <a:pPr>
+              <a:lnSpc>
+                <a:spcPct val="105000"/>
+              </a:lnSpc>
               <a:spcAft>
-                <a:spcPts val="1200"/>
+                <a:spcPts val="1000"/>
               </a:spcAft>
-              <a:defRPr sz="1900">
+              <a:defRPr sz="1500">
                 <a:solidFill>
                   <a:srgbClr val="1B2A4A"/>
                 </a:solidFill>
               </a:defRPr>
             </a:pPr>
             <a:r>
-              <a:t>•  Built from four parts: volume × intensity × exposure × persistence.</a:t>
+              <a:t>•  Map each violation type to an obstruction weight (how much it blocks the carriageway).</a:t>
             </a:r>
           </a:p>
           <a:p>
             <a:pPr>
+              <a:lnSpc>
+                <a:spcPct val="105000"/>
+              </a:lnSpc>
               <a:spcAft>
-                <a:spcPts val="1200"/>
+                <a:spcPts val="1000"/>
               </a:spcAft>
-              <a:defRPr sz="1900">
+              <a:defRPr sz="1500">
                 <a:solidFill>
                   <a:srgbClr val="1B2A4A"/>
                 </a:solidFill>
               </a:defRPr>
             </a:pPr>
             <a:r>
-              <a:t>•  Deliberately disagrees with a plain count (rank correlation 0.56).</a:t>
-            </a:r>
-          </a:p>
-        </p:txBody>
-      </p:sp>
-      <p:pic>
-        <p:nvPicPr>
-          <p:cNvPr id="5" name="Picture 4" descr="fig-concentration.png"/>
-          <p:cNvPicPr>
-            <a:picLocks noChangeAspect="1"/>
-          </p:cNvPicPr>
-          <p:nvPr/>
-        </p:nvPicPr>
-        <p:blipFill>
-          <a:blip r:embed="rId2"/>
-          <a:stretch>
-            <a:fillRect/>
-          </a:stretch>
-        </p:blipFill>
-        <p:spPr>
-          <a:xfrm>
-            <a:off x="6858000" y="1645920"/>
-            <a:ext cx="4846320" cy="3340499"/>
-          </a:xfrm>
-          <a:prstGeom prst="rect">
-            <a:avLst/>
-          </a:prstGeom>
-        </p:spPr>
-      </p:pic>
+              <a:t>•  Map each vehicle to a PCU footprint: a double-parked bus counts far more than a scooter.</a:t>
+            </a:r>
+          </a:p>
+          <a:p>
+            <a:pPr>
+              <a:lnSpc>
+                <a:spcPct val="105000"/>
+              </a:lnSpc>
+              <a:spcAft>
+                <a:spcPts val="1000"/>
+              </a:spcAft>
+              <a:defRPr sz="1500">
+                <a:solidFill>
+                  <a:srgbClr val="1B2A4A"/>
+                </a:solidFill>
+              </a:defRPr>
+            </a:pPr>
+            <a:r>
+              <a:t>•  Weight each record by an EXOGENOUS road-utilization curve by hour. This injects traffic flow without a feed and dodges the confound.</a:t>
+            </a:r>
+          </a:p>
+          <a:p>
+            <a:pPr>
+              <a:lnSpc>
+                <a:spcPct val="105000"/>
+              </a:lnSpc>
+              <a:spcAft>
+                <a:spcPts val="1000"/>
+              </a:spcAft>
+              <a:defRPr sz="1500">
+                <a:solidFill>
+                  <a:srgbClr val="1B2A4A"/>
+                </a:solidFill>
+              </a:defRPr>
+            </a:pPr>
+            <a:r>
+              <a:t>•  Aggregate to H3 res-9 cells (about 150 m): 2,534 hotspot cells. Build the core on approved records.</a:t>
+            </a:r>
+          </a:p>
+        </p:txBody>
+      </p:sp>
     </p:spTree>
   </p:cSld>
   <p:clrMapOvr>
@@ -5898,6 +6903,7 @@
           <a:ln>
             <a:noFill/>
           </a:ln>
+          <a:effectLst/>
         </p:spPr>
         <p:style>
           <a:lnRef idx="1">
@@ -5944,14 +6950,14 @@
           <a:lstStyle/>
           <a:p>
             <a:pPr>
-              <a:defRPr sz="3000" b="1">
+              <a:defRPr sz="2800" b="1">
                 <a:solidFill>
                   <a:srgbClr val="1B2A4A"/>
                 </a:solidFill>
               </a:defRPr>
             </a:pPr>
             <a:r>
-              <a:t>See it re-rank</a:t>
+              <a:t>The Congestion Impact Score (0 to 100)</a:t>
             </a:r>
           </a:p>
         </p:txBody>
@@ -5964,8 +6970,8 @@
         </p:nvSpPr>
         <p:spPr>
           <a:xfrm>
-            <a:off x="640080" y="1554480"/>
-            <a:ext cx="6035040" cy="4754880"/>
+            <a:off x="640080" y="1508760"/>
+            <a:ext cx="6126480" cy="4937760"/>
           </a:xfrm>
           <a:prstGeom prst="rect">
             <a:avLst/>
@@ -5979,39 +6985,99 @@
           <a:lstStyle/>
           <a:p>
             <a:pPr>
+              <a:lnSpc>
+                <a:spcPct val="105000"/>
+              </a:lnSpc>
               <a:spcAft>
-                <a:spcPts val="1200"/>
+                <a:spcPts val="1000"/>
               </a:spcAft>
-              <a:defRPr sz="1900">
+              <a:defRPr sz="1500">
                 <a:solidFill>
                   <a:srgbClr val="1B2A4A"/>
                 </a:solidFill>
               </a:defRPr>
             </a:pPr>
             <a:r>
-              <a:t>•  Toggle the map between raw density and impact.</a:t>
+              <a:t>•  score = 100 x (Volume x Intensity x Exposure x Persistence) ^ 1/4, a geometric mean of percentile ranks.</a:t>
             </a:r>
           </a:p>
           <a:p>
             <a:pPr>
+              <a:lnSpc>
+                <a:spcPct val="105000"/>
+              </a:lnSpc>
               <a:spcAft>
-                <a:spcPts val="1200"/>
+                <a:spcPts val="1000"/>
               </a:spcAft>
-              <a:defRPr sz="1900">
+              <a:defRPr sz="1500">
                 <a:solidFill>
                   <a:srgbClr val="1B2A4A"/>
                 </a:solidFill>
               </a:defRPr>
             </a:pPr>
             <a:r>
-              <a:t>•  Pre-dawn sweep clusters fade. Rush-hour chokepoints take over.</a:t>
+              <a:t>•  Volume: how many violations, shrunk so a single-event fluke can't top the list.</a:t>
+            </a:r>
+          </a:p>
+          <a:p>
+            <a:pPr>
+              <a:lnSpc>
+                <a:spcPct val="105000"/>
+              </a:lnSpc>
+              <a:spcAft>
+                <a:spcPts val="1000"/>
+              </a:spcAft>
+              <a:defRPr sz="1500">
+                <a:solidFill>
+                  <a:srgbClr val="1B2A4A"/>
+                </a:solidFill>
+              </a:defRPr>
+            </a:pPr>
+            <a:r>
+              <a:t>•  Intensity: how obstructive the typical violation is (carriageway, vehicle footprint, junction adjacency).</a:t>
+            </a:r>
+          </a:p>
+          <a:p>
+            <a:pPr>
+              <a:lnSpc>
+                <a:spcPct val="105000"/>
+              </a:lnSpc>
+              <a:spcAft>
+                <a:spcPts val="1000"/>
+              </a:spcAft>
+              <a:defRPr sz="1500">
+                <a:solidFill>
+                  <a:srgbClr val="1B2A4A"/>
+                </a:solidFill>
+              </a:defRPr>
+            </a:pPr>
+            <a:r>
+              <a:t>•  Exposure: how busy the road normally is. Persistence: how chronic the spot is.</a:t>
+            </a:r>
+          </a:p>
+          <a:p>
+            <a:pPr>
+              <a:lnSpc>
+                <a:spcPct val="105000"/>
+              </a:lnSpc>
+              <a:spcAft>
+                <a:spcPts val="1000"/>
+              </a:spcAft>
+              <a:defRPr sz="1500">
+                <a:solidFill>
+                  <a:srgbClr val="1B2A4A"/>
+                </a:solidFill>
+              </a:defRPr>
+            </a:pPr>
+            <a:r>
+              <a:t>•  Deliberately decoupled from a raw count (rank correlation 0.56). The top 1% of cells carry 35% of impact.</a:t>
             </a:r>
           </a:p>
         </p:txBody>
       </p:sp>
       <p:pic>
         <p:nvPicPr>
-          <p:cNvPr id="5" name="Picture 4" descr="fig-map.png"/>
+          <p:cNvPr id="5" name="Picture 4" descr="fig-concentration.png"/>
           <p:cNvPicPr>
             <a:picLocks noChangeAspect="1"/>
           </p:cNvPicPr>
@@ -6025,8 +7091,8 @@
         </p:blipFill>
         <p:spPr>
           <a:xfrm>
-            <a:off x="6858000" y="1645920"/>
-            <a:ext cx="4846320" cy="4424901"/>
+            <a:off x="6949440" y="1600200"/>
+            <a:ext cx="4754880" cy="3277471"/>
           </a:xfrm>
           <a:prstGeom prst="rect">
             <a:avLst/>
@@ -6071,6 +7137,7 @@
           <a:ln>
             <a:noFill/>
           </a:ln>
+          <a:effectLst/>
         </p:spPr>
         <p:style>
           <a:lnRef idx="1">
@@ -6117,14 +7184,14 @@
           <a:lstStyle/>
           <a:p>
             <a:pPr>
-              <a:defRPr sz="3000" b="1">
+              <a:defRPr sz="2800" b="1">
                 <a:solidFill>
                   <a:srgbClr val="1B2A4A"/>
                 </a:solidFill>
               </a:defRPr>
             </a:pPr>
             <a:r>
-              <a:t>From map to shortlist</a:t>
+              <a:t>The impact map: watch the city re-rank</a:t>
             </a:r>
           </a:p>
         </p:txBody>
@@ -6137,8 +7204,8 @@
         </p:nvSpPr>
         <p:spPr>
           <a:xfrm>
-            <a:off x="640080" y="1554480"/>
-            <a:ext cx="10789920" cy="4754880"/>
+            <a:off x="640080" y="1508760"/>
+            <a:ext cx="6126480" cy="4937760"/>
           </a:xfrm>
           <a:prstGeom prst="rect">
             <a:avLst/>
@@ -6152,51 +7219,102 @@
           <a:lstStyle/>
           <a:p>
             <a:pPr>
+              <a:lnSpc>
+                <a:spcPct val="105000"/>
+              </a:lnSpc>
               <a:spcAft>
-                <a:spcPts val="1200"/>
+                <a:spcPts val="1000"/>
               </a:spcAft>
-              <a:defRPr sz="1900">
+              <a:defRPr sz="1700">
                 <a:solidFill>
                   <a:srgbClr val="1B2A4A"/>
                 </a:solidFill>
               </a:defRPr>
             </a:pPr>
             <a:r>
-              <a:t>•  The top 30 cells, ranked.</a:t>
+              <a:t>•  Every cell (about 150 m) is colored by its Congestion Impact Score.</a:t>
             </a:r>
           </a:p>
           <a:p>
             <a:pPr>
+              <a:lnSpc>
+                <a:spcPct val="105000"/>
+              </a:lnSpc>
               <a:spcAft>
-                <a:spcPts val="1200"/>
+                <a:spcPts val="1000"/>
               </a:spcAft>
-              <a:defRPr sz="1900">
+              <a:defRPr sz="1700">
                 <a:solidFill>
                   <a:srgbClr val="1B2A4A"/>
                 </a:solidFill>
               </a:defRPr>
             </a:pPr>
             <a:r>
-              <a:t>•  Each with its main violation, the streets involved, and a two-hour window.</a:t>
+              <a:t>•  Toggle raw count to impact: the pre-dawn-sweep clusters fade, the real chokepoints light up.</a:t>
             </a:r>
           </a:p>
           <a:p>
             <a:pPr>
+              <a:lnSpc>
+                <a:spcPct val="105000"/>
+              </a:lnSpc>
               <a:spcAft>
-                <a:spcPts val="1200"/>
+                <a:spcPts val="1000"/>
               </a:spcAft>
-              <a:defRPr sz="1900">
+              <a:defRPr sz="1700">
                 <a:solidFill>
                   <a:srgbClr val="1B2A4A"/>
                 </a:solidFill>
               </a:defRPr>
             </a:pPr>
             <a:r>
-              <a:t>•  Where and when, not just where.</a:t>
-            </a:r>
-          </a:p>
-        </p:txBody>
-      </p:sp>
+              <a:t>•  Hover any cell for its breakdown: the four axes, its estimated cost, and a rising or cooling tag.</a:t>
+            </a:r>
+          </a:p>
+          <a:p>
+            <a:pPr>
+              <a:lnSpc>
+                <a:spcPct val="105000"/>
+              </a:lnSpc>
+              <a:spcAft>
+                <a:spcPts val="1000"/>
+              </a:spcAft>
+              <a:defRPr sz="1700">
+                <a:solidFill>
+                  <a:srgbClr val="1B2A4A"/>
+                </a:solidFill>
+              </a:defRPr>
+            </a:pPr>
+            <a:r>
+              <a:t>•  The bright core is the known commercial belt: Shivajinagar, Majestic, City Market, Malleshwaram.</a:t>
+            </a:r>
+          </a:p>
+        </p:txBody>
+      </p:sp>
+      <p:pic>
+        <p:nvPicPr>
+          <p:cNvPr id="5" name="Picture 4" descr="fig-map.png"/>
+          <p:cNvPicPr>
+            <a:picLocks noChangeAspect="1"/>
+          </p:cNvPicPr>
+          <p:nvPr/>
+        </p:nvPicPr>
+        <p:blipFill>
+          <a:blip r:embed="rId2"/>
+          <a:stretch>
+            <a:fillRect/>
+          </a:stretch>
+        </p:blipFill>
+        <p:spPr>
+          <a:xfrm>
+            <a:off x="6949440" y="1600200"/>
+            <a:ext cx="4754880" cy="4341412"/>
+          </a:xfrm>
+          <a:prstGeom prst="rect">
+            <a:avLst/>
+          </a:prstGeom>
+        </p:spPr>
+      </p:pic>
     </p:spTree>
   </p:cSld>
   <p:clrMapOvr>
@@ -6235,6 +7353,7 @@
           <a:ln>
             <a:noFill/>
           </a:ln>
+          <a:effectLst/>
         </p:spPr>
         <p:style>
           <a:lnRef idx="1">
@@ -6281,14 +7400,14 @@
           <a:lstStyle/>
           <a:p>
             <a:pPr>
-              <a:defRPr sz="3000" b="1">
+              <a:defRPr sz="2800" b="1">
                 <a:solidFill>
                   <a:srgbClr val="1B2A4A"/>
                 </a:solidFill>
               </a:defRPr>
             </a:pPr>
             <a:r>
-              <a:t>The forecasting model</a:t>
+              <a:t>Ranked zones: where AND when</a:t>
             </a:r>
           </a:p>
         </p:txBody>
@@ -6301,8 +7420,8 @@
         </p:nvSpPr>
         <p:spPr>
           <a:xfrm>
-            <a:off x="640080" y="1554480"/>
-            <a:ext cx="6035040" cy="4754880"/>
+            <a:off x="640080" y="1508760"/>
+            <a:ext cx="10881360" cy="4937760"/>
           </a:xfrm>
           <a:prstGeom prst="rect">
             <a:avLst/>
@@ -6316,75 +7435,78 @@
           <a:lstStyle/>
           <a:p>
             <a:pPr>
+              <a:lnSpc>
+                <a:spcPct val="105000"/>
+              </a:lnSpc>
               <a:spcAft>
-                <a:spcPts val="1200"/>
+                <a:spcPts val="1000"/>
               </a:spcAft>
-              <a:defRPr sz="1900">
+              <a:defRPr sz="1700">
                 <a:solidFill>
                   <a:srgbClr val="1B2A4A"/>
                 </a:solidFill>
               </a:defRPr>
             </a:pPr>
             <a:r>
-              <a:t>•  Forecasts next-day violations per cell. Trained on past months, tested on unseen ones.</a:t>
+              <a:t>•  The top 30 cells, each with its dominant violation, the streets involved, and an exposure-weighted window.</a:t>
             </a:r>
           </a:p>
           <a:p>
             <a:pPr>
+              <a:lnSpc>
+                <a:spcPct val="105000"/>
+              </a:lnSpc>
               <a:spcAft>
-                <a:spcPts val="1200"/>
+                <a:spcPts val="1000"/>
               </a:spcAft>
-              <a:defRPr sz="1900">
+              <a:defRPr sz="1700">
                 <a:solidFill>
                   <a:srgbClr val="1B2A4A"/>
                 </a:solidFill>
               </a:defRPr>
             </a:pPr>
             <a:r>
-              <a:t>•  Beats the standard seasonal baseline by 36% on next-day hit rate.</a:t>
+              <a:t>•  Validated without ground truth: face validity, where 20 of the top 20 are known chokepoints.</a:t>
             </a:r>
           </a:p>
           <a:p>
             <a:pPr>
+              <a:lnSpc>
+                <a:spcPct val="105000"/>
+              </a:lnSpc>
               <a:spcAft>
-                <a:spcPts val="1200"/>
+                <a:spcPts val="1000"/>
               </a:spcAft>
-              <a:defRPr sz="1900">
+              <a:defRPr sz="1700">
                 <a:solidFill>
                   <a:srgbClr val="1B2A4A"/>
                 </a:solidFill>
               </a:defRPr>
             </a:pPr>
             <a:r>
-              <a:t>•  We tried 29 more features and heavier models. None beat the simple base set.</a:t>
-            </a:r>
-          </a:p>
-        </p:txBody>
-      </p:sp>
-      <p:pic>
-        <p:nvPicPr>
-          <p:cNvPr id="5" name="Picture 4" descr="fig-forecast.png"/>
-          <p:cNvPicPr>
-            <a:picLocks noChangeAspect="1"/>
-          </p:cNvPicPr>
-          <p:nvPr/>
-        </p:nvPicPr>
-        <p:blipFill>
-          <a:blip r:embed="rId2"/>
-          <a:stretch>
-            <a:fillRect/>
-          </a:stretch>
-        </p:blipFill>
-        <p:spPr>
-          <a:xfrm>
-            <a:off x="6858000" y="1645920"/>
-            <a:ext cx="4846320" cy="2868027"/>
-          </a:xfrm>
-          <a:prstGeom prst="rect">
-            <a:avLst/>
-          </a:prstGeom>
-        </p:spPr>
-      </p:pic>
+              <a:t>•  Stability: the ranking holds month to month (rank correlation about 0.75 to 0.86).</a:t>
+            </a:r>
+          </a:p>
+          <a:p>
+            <a:pPr>
+              <a:lnSpc>
+                <a:spcPct val="105000"/>
+              </a:lnSpc>
+              <a:spcAft>
+                <a:spcPts val="1000"/>
+              </a:spcAft>
+              <a:defRPr sz="1700">
+                <a:solidFill>
+                  <a:srgbClr val="1B2A4A"/>
+                </a:solidFill>
+              </a:defRPr>
+            </a:pPr>
+            <a:r>
+              <a:t>•  This is the ops payload: a shortlist an officer can act on tomorrow.</a:t>
+            </a:r>
+          </a:p>
+        </p:txBody>
+      </p:sp>
     </p:spTree>
   </p:cSld>
   <p:clrMapOvr>
@@ -6423,6 +7545,7 @@
           <a:ln>
             <a:noFill/>
           </a:ln>
+          <a:effectLst/>
         </p:spPr>
         <p:style>
           <a:lnRef idx="1">
@@ -6469,14 +7592,14 @@
           <a:lstStyle/>
           <a:p>
             <a:pPr>
-              <a:defRPr sz="3000" b="1">
+              <a:defRPr sz="2800" b="1">
                 <a:solidFill>
                   <a:srgbClr val="1B2A4A"/>
                 </a:solidFill>
               </a:defRPr>
             </a:pPr>
             <a:r>
-              <a:t>Turn it into a patrol plan</a:t>
+              <a:t>The visibility gap: effort vs impact</a:t>
             </a:r>
           </a:p>
         </p:txBody>
@@ -6489,8 +7612,8 @@
         </p:nvSpPr>
         <p:spPr>
           <a:xfrm>
-            <a:off x="640080" y="1554480"/>
-            <a:ext cx="6035040" cy="4754880"/>
+            <a:off x="640080" y="1508760"/>
+            <a:ext cx="6126480" cy="4937760"/>
           </a:xfrm>
           <a:prstGeom prst="rect">
             <a:avLst/>
@@ -6504,54 +7627,81 @@
           <a:lstStyle/>
           <a:p>
             <a:pPr>
+              <a:lnSpc>
+                <a:spcPct val="105000"/>
+              </a:lnSpc>
               <a:spcAft>
-                <a:spcPts val="1200"/>
+                <a:spcPts val="1000"/>
               </a:spcAft>
-              <a:defRPr sz="1900">
+              <a:defRPr sz="1700">
                 <a:solidFill>
                   <a:srgbClr val="1B2A4A"/>
                 </a:solidFill>
               </a:defRPr>
             </a:pPr>
             <a:r>
-              <a:t>•  A greedy optimizer assigns N patrol beats for maximum impact covered.</a:t>
+              <a:t>•  Recorded violations double as a map of enforcement EFFORT.</a:t>
             </a:r>
           </a:p>
           <a:p>
             <a:pPr>
+              <a:lnSpc>
+                <a:spcPct val="105000"/>
+              </a:lnSpc>
               <a:spcAft>
-                <a:spcPts val="1200"/>
+                <a:spcPts val="1000"/>
               </a:spcAft>
-              <a:defRPr sz="1900">
+              <a:defRPr sz="1700">
                 <a:solidFill>
                   <a:srgbClr val="1B2A4A"/>
                 </a:solidFill>
               </a:defRPr>
             </a:pPr>
             <a:r>
-              <a:t>•  20 patrols cover 53% of citywide impact, against 47% for a naive top-20.</a:t>
+              <a:t>•  Weight each by its impact unit (obstruction x PCU x utilization) to see what that effort actually buys.</a:t>
             </a:r>
           </a:p>
           <a:p>
             <a:pPr>
+              <a:lnSpc>
+                <a:spcPct val="105000"/>
+              </a:lnSpc>
               <a:spcAft>
-                <a:spcPts val="1200"/>
+                <a:spcPts val="1000"/>
               </a:spcAft>
-              <a:defRPr sz="1900">
+              <a:defRPr sz="1700">
                 <a:solidFill>
                   <a:srgbClr val="1B2A4A"/>
                 </a:solidFill>
               </a:defRPr>
             </a:pPr>
             <a:r>
-              <a:t>•  Live slider: pick your fleet size, get the plan.</a:t>
+              <a:t>•  The 4-5am sweep: 15% of effort, 4% of impact. The night window: 34% of effort, 8% of impact.</a:t>
+            </a:r>
+          </a:p>
+          <a:p>
+            <a:pPr>
+              <a:lnSpc>
+                <a:spcPct val="105000"/>
+              </a:lnSpc>
+              <a:spcAft>
+                <a:spcPts val="1000"/>
+              </a:spcAft>
+              <a:defRPr sz="1700">
+                <a:solidFill>
+                  <a:srgbClr val="1B2A4A"/>
+                </a:solidFill>
+              </a:defRPr>
+            </a:pPr>
+            <a:r>
+              <a:t>•  Peak hours are the reverse: 29% of effort, 50% of impact. ParkPulse redirects effort to where it matters.</a:t>
             </a:r>
           </a:p>
         </p:txBody>
       </p:sp>
       <p:pic>
         <p:nvPicPr>
-          <p:cNvPr id="5" name="Picture 4" descr="fig-coverage.png"/>
+          <p:cNvPr id="5" name="Picture 4" descr="fig-gap.png"/>
           <p:cNvPicPr>
             <a:picLocks noChangeAspect="1"/>
           </p:cNvPicPr>
@@ -6565,8 +7715,8 @@
         </p:blipFill>
         <p:spPr>
           <a:xfrm>
-            <a:off x="6858000" y="1645920"/>
-            <a:ext cx="4846320" cy="3305087"/>
+            <a:off x="6949440" y="1600200"/>
+            <a:ext cx="4754880" cy="3186722"/>
           </a:xfrm>
           <a:prstGeom prst="rect">
             <a:avLst/>

</xml_diff>

<commit_message>
Add impact-score robustness analysis (answers "why those weights?")
score_robustness.py re-weights the four impact axes across 2,000 random
weightings (each varied up to 3x in relative importance) and measures how much
the top-zone ranking moves:
- median Spearman 0.97 vs the shipped score; top-20 retains 18/20 on average
- arithmetic vs geometric mean still correlates 0.86
- no single axis dominates (drop-one Spearman > 0.82)

So the ranking reflects the data's structure, not a hand-tuned weighting.
Surfaced in the LaTeX/solution doc (new fig-robustness), the .pptx deck, and the
web methodology card; docs + changelog updated.

Co-Authored-By: Claude Opus 4.8 <noreply@anthropic.com>
Claude-Session: https://claude.ai/code/session_015xqbLKu3bgv91jhV9ZLyyM
</commit_message>
<xml_diff>
--- a/submission/ParkPulse_Pitch_Deck.pptx
+++ b/submission/ParkPulse_Pitch_Deck.pptx
@@ -5779,7 +5779,7 @@
               <a:spcAft>
                 <a:spcPts val="1000"/>
               </a:spcAft>
-              <a:defRPr sz="1700">
+              <a:defRPr sz="1500">
                 <a:solidFill>
                   <a:srgbClr val="1B2A4A"/>
                 </a:solidFill>
@@ -5797,14 +5797,14 @@
               <a:spcAft>
                 <a:spcPts val="1000"/>
               </a:spcAft>
-              <a:defRPr sz="1700">
+              <a:defRPr sz="1500">
                 <a:solidFill>
                   <a:srgbClr val="1B2A4A"/>
                 </a:solidFill>
               </a:defRPr>
             </a:pPr>
             <a:r>
-              <a:t>•  The enforcement confound: we weight by exogenous exposure, never the recorded hour.</a:t>
+              <a:t>•  Robust to the weights: across 2,000 random axis weightings the top-20 ranking holds (median rank-corr 0.97), so the score isn't a hand-tuned artefact.</a:t>
             </a:r>
           </a:p>
           <a:p>
@@ -5815,14 +5815,14 @@
               <a:spcAft>
                 <a:spcPts val="1000"/>
               </a:spcAft>
-              <a:defRPr sz="1700">
+              <a:defRPr sz="1500">
                 <a:solidFill>
                   <a:srgbClr val="1B2A4A"/>
                 </a:solidFill>
               </a:defRPr>
             </a:pPr>
             <a:r>
-              <a:t>•  The data can't see the evening (enforcement rarely works evenings), so we don't fake an hour-by-hour schedule.</a:t>
+              <a:t>•  The enforcement confound: we weight by exogenous exposure, never the recorded hour.</a:t>
             </a:r>
           </a:p>
           <a:p>
@@ -5833,7 +5833,25 @@
               <a:spcAft>
                 <a:spcPts val="1000"/>
               </a:spcAft>
-              <a:defRPr sz="1700">
+              <a:defRPr sz="1500">
+                <a:solidFill>
+                  <a:srgbClr val="1B2A4A"/>
+                </a:solidFill>
+              </a:defRPr>
+            </a:pPr>
+            <a:r>
+              <a:t>•  The data can't see the evening (enforcement rarely works evenings), so we don't fake an hour-by-hour schedule.</a:t>
+            </a:r>
+          </a:p>
+          <a:p>
+            <a:pPr>
+              <a:lnSpc>
+                <a:spcPct val="105000"/>
+              </a:lnSpc>
+              <a:spcAft>
+                <a:spcPts val="1000"/>
+              </a:spcAft>
+              <a:defRPr sz="1500">
                 <a:solidFill>
                   <a:srgbClr val="1B2A4A"/>
                 </a:solidFill>

</xml_diff>